<commit_message>
Update paper and talk with corrected numbers and new figures
Paper (main.tex / main (12).pdf):
- 3/8 pancreatic → 5/8 pancreatic invisible states
- Epsilon silhouette 0.215/-0.011 → 0.276/-0.042
- Temporal precedence 54% → 63% pancreas (p=5.3e-6)
- PT velocity cosine 0.04 → -0.056
- RBP uncorrected 99.4% → 98.9% destabilizing
- Added LaTeX source (main.tex) referencing fig_*.png

Talk (scPTR talk.pptx):
- Same text corrections on slides 14, 21, 24
- 8 new figure slides added: invisible states pancreas/DG,
  epsilon UMAPs, permutation control, gamma leads expression,
  PT velocity orthogonality, library-size correction, DepMap
</commit_message>
<xml_diff>
--- a/presentations/scPTR talk.pptx
+++ b/presentations/scPTR talk.pptx
@@ -22,10 +22,18 @@
     <p:sldId id="267" r:id="rId16"/>
     <p:sldId id="268" r:id="rId17"/>
     <p:sldId id="269" r:id="rId18"/>
+    <p:sldId id="279" r:id="rId28"/>
+    <p:sldId id="280" r:id="rId29"/>
+    <p:sldId id="281" r:id="rId30"/>
+    <p:sldId id="282" r:id="rId31"/>
     <p:sldId id="270" r:id="rId19"/>
     <p:sldId id="271" r:id="rId20"/>
     <p:sldId id="272" r:id="rId21"/>
+    <p:sldId id="283" r:id="rId32"/>
+    <p:sldId id="284" r:id="rId33"/>
     <p:sldId id="273" r:id="rId22"/>
+    <p:sldId id="285" r:id="rId34"/>
+    <p:sldId id="286" r:id="rId35"/>
     <p:sldId id="274" r:id="rId23"/>
     <p:sldId id="275" r:id="rId24"/>
     <p:sldId id="276" r:id="rId25"/>
@@ -8842,7 +8850,7 @@
                   <a:schemeClr val="dk1"/>
                 </a:solidFill>
               </a:rPr>
-              <a:t>Clustering in γ-space reveals substructure in 3 of 8 pancreatic and 6 of 11 hippocampal cell types.</a:t>
+              <a:t>Clustering in γ-space reveals substructure in 5 of 8 pancreatic and 6 of 11 hippocampal cell types.</a:t>
             </a:r>
             <a:endParaRPr sz="2000">
               <a:solidFill>
@@ -8901,7 +8909,7 @@
                   <a:schemeClr val="dk1"/>
                 </a:solidFill>
               </a:rPr>
-              <a:t>Pancreatic Epsilon cells: silhouette 0.215 in γ-space vs −0.011 in expression — one blob by expression, cleanly split by degradation.</a:t>
+              <a:t>Pancreatic Epsilon cells: silhouette 0.276 in γ-space vs −0.042 in expression — one blob by expression, cleanly split by degradation.</a:t>
             </a:r>
             <a:endParaRPr sz="2000">
               <a:solidFill>
@@ -9466,7 +9474,7 @@
                 <a:cs typeface="Arial"/>
                 <a:sym typeface="Arial"/>
               </a:rPr>
-              <a:t> (cosine ≈ 0.04): the two axes carry independent information.</a:t>
+              <a:t> (cosine ≈ −0.06): the two axes carry independent information.</a:t>
             </a:r>
             <a:endParaRPr b="0" i="0" sz="2200" u="none" cap="none" strike="noStrike">
               <a:solidFill>
@@ -9589,7 +9597,7 @@
                 <a:cs typeface="Arial"/>
                 <a:sym typeface="Arial"/>
               </a:rPr>
-              <a:t>54% of pancreas (p&lt;10⁻⁵⁷), 78% of dentate gyrus, 61% of A549 transition genes.</a:t>
+              <a:t>63% of pancreas (p=5.3×10⁻⁶), 78% of dentate gyrus, 61% of A549 transition genes.</a:t>
             </a:r>
             <a:endParaRPr b="0" i="0" sz="2200" u="none" cap="none" strike="noStrike">
               <a:solidFill>
@@ -9840,7 +9848,7 @@
                   <a:schemeClr val="dk1"/>
                 </a:solidFill>
               </a:rPr>
-              <a:t>Uncorrected inference is 99.4% destabilising (depth confound); correction drops 11,847 spurious edges → balanced 53/47.</a:t>
+              <a:t>Uncorrected inference is 98.9% destabilising (depth confound); correction drops 11,847 spurious edges → balanced 53/47.</a:t>
             </a:r>
             <a:endParaRPr i="0" sz="1700" u="none" cap="none" strike="noStrike">
               <a:solidFill>
@@ -15978,6 +15986,510 @@
 </p:sld>
 </file>
 
+<file path=ppt/slides/slide24.xml><?xml version="1.0" encoding="utf-8"?>
+<p:sld xmlns:a="http://schemas.openxmlformats.org/drawingml/2006/main" xmlns:p="http://schemas.openxmlformats.org/presentationml/2006/main" xmlns:r="http://schemas.openxmlformats.org/officeDocument/2006/relationships">
+  <p:cSld>
+    <p:bg>
+      <p:bgPr>
+        <a:solidFill>
+          <a:srgbClr val="FFFFFF"/>
+        </a:solidFill>
+        <a:effectLst/>
+      </p:bgPr>
+    </p:bg>
+    <p:spTree>
+      <p:nvGrpSpPr>
+        <p:cNvPr id="1" name=""/>
+        <p:cNvGrpSpPr/>
+        <p:nvPr/>
+      </p:nvGrpSpPr>
+      <p:grpSpPr/>
+      <p:pic>
+        <p:nvPicPr>
+          <p:cNvPr id="2" name="Picture 1" descr="fig_invisible_states_pancreas.png"/>
+          <p:cNvPicPr>
+            <a:picLocks noChangeAspect="1"/>
+          </p:cNvPicPr>
+          <p:nvPr/>
+        </p:nvPicPr>
+        <p:blipFill>
+          <a:blip r:embed="rId2"/>
+          <a:stretch>
+            <a:fillRect/>
+          </a:stretch>
+        </p:blipFill>
+        <p:spPr>
+          <a:xfrm>
+            <a:off x="914400" y="205740"/>
+            <a:ext cx="10363200" cy="5932170"/>
+          </a:xfrm>
+          <a:prstGeom prst="rect">
+            <a:avLst/>
+          </a:prstGeom>
+        </p:spPr>
+      </p:pic>
+      <p:sp>
+        <p:nvSpPr>
+          <p:cNvPr id="3" name="TextBox 2"/>
+          <p:cNvSpPr txBox="1"/>
+          <p:nvPr/>
+        </p:nvSpPr>
+        <p:spPr>
+          <a:xfrm>
+            <a:off x="609600" y="6206490"/>
+            <a:ext cx="10972800" cy="548640"/>
+          </a:xfrm>
+          <a:prstGeom prst="rect">
+            <a:avLst/>
+          </a:prstGeom>
+          <a:noFill/>
+        </p:spPr>
+        <p:txBody>
+          <a:bodyPr wrap="square">
+            <a:spAutoFit/>
+          </a:bodyPr>
+          <a:lstStyle/>
+          <a:p>
+            <a:pPr algn="ctr"/>
+            <a:r>
+              <a:rPr sz="1300">
+                <a:solidFill>
+                  <a:srgbClr val="444444"/>
+                </a:solidFill>
+              </a:rPr>
+              <a:t>Silhouette of γ-space labels in both spaces. 5/8 pancreatic cell types show stronger γ-space than expression-space substructure.</a:t>
+            </a:r>
+          </a:p>
+        </p:txBody>
+      </p:sp>
+    </p:spTree>
+  </p:cSld>
+  <p:clrMapOvr>
+    <a:masterClrMapping/>
+  </p:clrMapOvr>
+</p:sld>
+</file>
+
+<file path=ppt/slides/slide25.xml><?xml version="1.0" encoding="utf-8"?>
+<p:sld xmlns:a="http://schemas.openxmlformats.org/drawingml/2006/main" xmlns:p="http://schemas.openxmlformats.org/presentationml/2006/main" xmlns:r="http://schemas.openxmlformats.org/officeDocument/2006/relationships">
+  <p:cSld>
+    <p:bg>
+      <p:bgPr>
+        <a:solidFill>
+          <a:srgbClr val="FFFFFF"/>
+        </a:solidFill>
+        <a:effectLst/>
+      </p:bgPr>
+    </p:bg>
+    <p:spTree>
+      <p:nvGrpSpPr>
+        <p:cNvPr id="1" name=""/>
+        <p:cNvGrpSpPr/>
+        <p:nvPr/>
+      </p:nvGrpSpPr>
+      <p:grpSpPr/>
+      <p:pic>
+        <p:nvPicPr>
+          <p:cNvPr id="2" name="Picture 1" descr="fig_invisible_states_dentate.png"/>
+          <p:cNvPicPr>
+            <a:picLocks noChangeAspect="1"/>
+          </p:cNvPicPr>
+          <p:nvPr/>
+        </p:nvPicPr>
+        <p:blipFill>
+          <a:blip r:embed="rId2"/>
+          <a:stretch>
+            <a:fillRect/>
+          </a:stretch>
+        </p:blipFill>
+        <p:spPr>
+          <a:xfrm>
+            <a:off x="914400" y="205740"/>
+            <a:ext cx="10363200" cy="5932170"/>
+          </a:xfrm>
+          <a:prstGeom prst="rect">
+            <a:avLst/>
+          </a:prstGeom>
+        </p:spPr>
+      </p:pic>
+      <p:sp>
+        <p:nvSpPr>
+          <p:cNvPr id="3" name="TextBox 2"/>
+          <p:cNvSpPr txBox="1"/>
+          <p:nvPr/>
+        </p:nvSpPr>
+        <p:spPr>
+          <a:xfrm>
+            <a:off x="609600" y="6206490"/>
+            <a:ext cx="10972800" cy="548640"/>
+          </a:xfrm>
+          <a:prstGeom prst="rect">
+            <a:avLst/>
+          </a:prstGeom>
+          <a:noFill/>
+        </p:spPr>
+        <p:txBody>
+          <a:bodyPr wrap="square">
+            <a:spAutoFit/>
+          </a:bodyPr>
+          <a:lstStyle/>
+          <a:p>
+            <a:pPr algn="ctr"/>
+            <a:r>
+              <a:rPr sz="1300">
+                <a:solidFill>
+                  <a:srgbClr val="444444"/>
+                </a:solidFill>
+              </a:rPr>
+              <a:t>6/11 hippocampal cell types show γ-space substructure invisible or reduced in expression space.</a:t>
+            </a:r>
+          </a:p>
+        </p:txBody>
+      </p:sp>
+    </p:spTree>
+  </p:cSld>
+  <p:clrMapOvr>
+    <a:masterClrMapping/>
+  </p:clrMapOvr>
+</p:sld>
+</file>
+
+<file path=ppt/slides/slide26.xml><?xml version="1.0" encoding="utf-8"?>
+<p:sld xmlns:a="http://schemas.openxmlformats.org/drawingml/2006/main" xmlns:p="http://schemas.openxmlformats.org/presentationml/2006/main" xmlns:r="http://schemas.openxmlformats.org/officeDocument/2006/relationships">
+  <p:cSld>
+    <p:bg>
+      <p:bgPr>
+        <a:solidFill>
+          <a:srgbClr val="FFFFFF"/>
+        </a:solidFill>
+        <a:effectLst/>
+      </p:bgPr>
+    </p:bg>
+    <p:spTree>
+      <p:nvGrpSpPr>
+        <p:cNvPr id="1" name=""/>
+        <p:cNvGrpSpPr/>
+        <p:nvPr/>
+      </p:nvGrpSpPr>
+      <p:grpSpPr/>
+      <p:pic>
+        <p:nvPicPr>
+          <p:cNvPr id="2" name="Picture 1" descr="fig_invisible_epsilon.png"/>
+          <p:cNvPicPr>
+            <a:picLocks noChangeAspect="1"/>
+          </p:cNvPicPr>
+          <p:nvPr/>
+        </p:nvPicPr>
+        <p:blipFill>
+          <a:blip r:embed="rId2"/>
+          <a:stretch>
+            <a:fillRect/>
+          </a:stretch>
+        </p:blipFill>
+        <p:spPr>
+          <a:xfrm>
+            <a:off x="914400" y="205740"/>
+            <a:ext cx="10363200" cy="5932170"/>
+          </a:xfrm>
+          <a:prstGeom prst="rect">
+            <a:avLst/>
+          </a:prstGeom>
+        </p:spPr>
+      </p:pic>
+      <p:sp>
+        <p:nvSpPr>
+          <p:cNvPr id="3" name="TextBox 2"/>
+          <p:cNvSpPr txBox="1"/>
+          <p:nvPr/>
+        </p:nvSpPr>
+        <p:spPr>
+          <a:xfrm>
+            <a:off x="609600" y="6206490"/>
+            <a:ext cx="10972800" cy="548640"/>
+          </a:xfrm>
+          <a:prstGeom prst="rect">
+            <a:avLst/>
+          </a:prstGeom>
+          <a:noFill/>
+        </p:spPr>
+        <p:txBody>
+          <a:bodyPr wrap="square">
+            <a:spAutoFit/>
+          </a:bodyPr>
+          <a:lstStyle/>
+          <a:p>
+            <a:pPr algn="ctr"/>
+            <a:r>
+              <a:rPr sz="1300">
+                <a:solidFill>
+                  <a:srgbClr val="444444"/>
+                </a:solidFill>
+              </a:rPr>
+              <a:t>Epsilon cells (n=142): one blob in expression (silhouette −0.042), cleanly split in γ-space (silhouette 0.276).</a:t>
+            </a:r>
+          </a:p>
+        </p:txBody>
+      </p:sp>
+    </p:spTree>
+  </p:cSld>
+  <p:clrMapOvr>
+    <a:masterClrMapping/>
+  </p:clrMapOvr>
+</p:sld>
+</file>
+
+<file path=ppt/slides/slide27.xml><?xml version="1.0" encoding="utf-8"?>
+<p:sld xmlns:a="http://schemas.openxmlformats.org/drawingml/2006/main" xmlns:p="http://schemas.openxmlformats.org/presentationml/2006/main" xmlns:r="http://schemas.openxmlformats.org/officeDocument/2006/relationships">
+  <p:cSld>
+    <p:bg>
+      <p:bgPr>
+        <a:solidFill>
+          <a:srgbClr val="FFFFFF"/>
+        </a:solidFill>
+        <a:effectLst/>
+      </p:bgPr>
+    </p:bg>
+    <p:spTree>
+      <p:nvGrpSpPr>
+        <p:cNvPr id="1" name=""/>
+        <p:cNvGrpSpPr/>
+        <p:nvPr/>
+      </p:nvGrpSpPr>
+      <p:grpSpPr/>
+      <p:pic>
+        <p:nvPicPr>
+          <p:cNvPr id="2" name="Picture 1" descr="fig_permutation_control.png"/>
+          <p:cNvPicPr>
+            <a:picLocks noChangeAspect="1"/>
+          </p:cNvPicPr>
+          <p:nvPr/>
+        </p:nvPicPr>
+        <p:blipFill>
+          <a:blip r:embed="rId2"/>
+          <a:stretch>
+            <a:fillRect/>
+          </a:stretch>
+        </p:blipFill>
+        <p:spPr>
+          <a:xfrm>
+            <a:off x="914400" y="205740"/>
+            <a:ext cx="10363200" cy="5932170"/>
+          </a:xfrm>
+          <a:prstGeom prst="rect">
+            <a:avLst/>
+          </a:prstGeom>
+        </p:spPr>
+      </p:pic>
+      <p:sp>
+        <p:nvSpPr>
+          <p:cNvPr id="3" name="TextBox 2"/>
+          <p:cNvSpPr txBox="1"/>
+          <p:nvPr/>
+        </p:nvSpPr>
+        <p:spPr>
+          <a:xfrm>
+            <a:off x="609600" y="6206490"/>
+            <a:ext cx="10972800" cy="548640"/>
+          </a:xfrm>
+          <a:prstGeom prst="rect">
+            <a:avLst/>
+          </a:prstGeom>
+          <a:noFill/>
+        </p:spPr>
+        <p:txBody>
+          <a:bodyPr wrap="square">
+            <a:spAutoFit/>
+          </a:bodyPr>
+          <a:lstStyle/>
+          <a:p>
+            <a:pPr algn="ctr"/>
+            <a:r>
+              <a:rPr sz="1300">
+                <a:solidFill>
+                  <a:srgbClr val="444444"/>
+                </a:solidFill>
+              </a:rPr>
+              <a:t>Permutation control: shuffling u/s pairs within each gene before estimation yields ARI ≈ 0, ruling out smoothing artefacts.</a:t>
+            </a:r>
+          </a:p>
+        </p:txBody>
+      </p:sp>
+    </p:spTree>
+  </p:cSld>
+  <p:clrMapOvr>
+    <a:masterClrMapping/>
+  </p:clrMapOvr>
+</p:sld>
+</file>
+
+<file path=ppt/slides/slide28.xml><?xml version="1.0" encoding="utf-8"?>
+<p:sld xmlns:a="http://schemas.openxmlformats.org/drawingml/2006/main" xmlns:p="http://schemas.openxmlformats.org/presentationml/2006/main" xmlns:r="http://schemas.openxmlformats.org/officeDocument/2006/relationships">
+  <p:cSld>
+    <p:bg>
+      <p:bgPr>
+        <a:solidFill>
+          <a:srgbClr val="FFFFFF"/>
+        </a:solidFill>
+        <a:effectLst/>
+      </p:bgPr>
+    </p:bg>
+    <p:spTree>
+      <p:nvGrpSpPr>
+        <p:cNvPr id="1" name=""/>
+        <p:cNvGrpSpPr/>
+        <p:nvPr/>
+      </p:nvGrpSpPr>
+      <p:grpSpPr/>
+      <p:pic>
+        <p:nvPicPr>
+          <p:cNvPr id="2" name="Picture 1" descr="fig_gamma_leads_expression.png"/>
+          <p:cNvPicPr>
+            <a:picLocks noChangeAspect="1"/>
+          </p:cNvPicPr>
+          <p:nvPr/>
+        </p:nvPicPr>
+        <p:blipFill>
+          <a:blip r:embed="rId2"/>
+          <a:stretch>
+            <a:fillRect/>
+          </a:stretch>
+        </p:blipFill>
+        <p:spPr>
+          <a:xfrm>
+            <a:off x="914400" y="205740"/>
+            <a:ext cx="10363200" cy="5932170"/>
+          </a:xfrm>
+          <a:prstGeom prst="rect">
+            <a:avLst/>
+          </a:prstGeom>
+        </p:spPr>
+      </p:pic>
+      <p:sp>
+        <p:nvSpPr>
+          <p:cNvPr id="3" name="TextBox 2"/>
+          <p:cNvSpPr txBox="1"/>
+          <p:nvPr/>
+        </p:nvSpPr>
+        <p:spPr>
+          <a:xfrm>
+            <a:off x="609600" y="6206490"/>
+            <a:ext cx="10972800" cy="548640"/>
+          </a:xfrm>
+          <a:prstGeom prst="rect">
+            <a:avLst/>
+          </a:prstGeom>
+          <a:noFill/>
+        </p:spPr>
+        <p:txBody>
+          <a:bodyPr wrap="square">
+            <a:spAutoFit/>
+          </a:bodyPr>
+          <a:lstStyle/>
+          <a:p>
+            <a:pPr algn="ctr"/>
+            <a:r>
+              <a:rPr sz="1300">
+                <a:solidFill>
+                  <a:srgbClr val="444444"/>
+                </a:solidFill>
+              </a:rPr>
+              <a:t>γ leads expression at fate transitions: 63% of pancreatic genes (p=5.3×10⁻⁶), 78% of dentate gyrus genes (p=9.9×10⁻¹³).</a:t>
+            </a:r>
+          </a:p>
+        </p:txBody>
+      </p:sp>
+    </p:spTree>
+  </p:cSld>
+  <p:clrMapOvr>
+    <a:masterClrMapping/>
+  </p:clrMapOvr>
+</p:sld>
+</file>
+
+<file path=ppt/slides/slide29.xml><?xml version="1.0" encoding="utf-8"?>
+<p:sld xmlns:a="http://schemas.openxmlformats.org/drawingml/2006/main" xmlns:p="http://schemas.openxmlformats.org/presentationml/2006/main" xmlns:r="http://schemas.openxmlformats.org/officeDocument/2006/relationships">
+  <p:cSld>
+    <p:bg>
+      <p:bgPr>
+        <a:solidFill>
+          <a:srgbClr val="FFFFFF"/>
+        </a:solidFill>
+        <a:effectLst/>
+      </p:bgPr>
+    </p:bg>
+    <p:spTree>
+      <p:nvGrpSpPr>
+        <p:cNvPr id="1" name=""/>
+        <p:cNvGrpSpPr/>
+        <p:nvPr/>
+      </p:nvGrpSpPr>
+      <p:grpSpPr/>
+      <p:pic>
+        <p:nvPicPr>
+          <p:cNvPr id="2" name="Picture 1" descr="fig_pt_velocity_orthogonality.png"/>
+          <p:cNvPicPr>
+            <a:picLocks noChangeAspect="1"/>
+          </p:cNvPicPr>
+          <p:nvPr/>
+        </p:nvPicPr>
+        <p:blipFill>
+          <a:blip r:embed="rId2"/>
+          <a:stretch>
+            <a:fillRect/>
+          </a:stretch>
+        </p:blipFill>
+        <p:spPr>
+          <a:xfrm>
+            <a:off x="914400" y="205740"/>
+            <a:ext cx="10363200" cy="5932170"/>
+          </a:xfrm>
+          <a:prstGeom prst="rect">
+            <a:avLst/>
+          </a:prstGeom>
+        </p:spPr>
+      </p:pic>
+      <p:sp>
+        <p:nvSpPr>
+          <p:cNvPr id="3" name="TextBox 2"/>
+          <p:cNvSpPr txBox="1"/>
+          <p:nvPr/>
+        </p:nvSpPr>
+        <p:spPr>
+          <a:xfrm>
+            <a:off x="609600" y="6206490"/>
+            <a:ext cx="10972800" cy="548640"/>
+          </a:xfrm>
+          <a:prstGeom prst="rect">
+            <a:avLst/>
+          </a:prstGeom>
+          <a:noFill/>
+        </p:spPr>
+        <p:txBody>
+          <a:bodyPr wrap="square">
+            <a:spAutoFit/>
+          </a:bodyPr>
+          <a:lstStyle/>
+          <a:p>
+            <a:pPr algn="ctr"/>
+            <a:r>
+              <a:rPr sz="1300">
+                <a:solidFill>
+                  <a:srgbClr val="444444"/>
+                </a:solidFill>
+              </a:rPr>
+              <a:t>PT velocity approximately orthogonal to RNA velocity (mean cosine = −0.056), confirming independent information axes.</a:t>
+            </a:r>
+          </a:p>
+        </p:txBody>
+      </p:sp>
+    </p:spTree>
+  </p:cSld>
+  <p:clrMapOvr>
+    <a:masterClrMapping/>
+  </p:clrMapOvr>
+</p:sld>
+</file>
+
 <file path=ppt/slides/slide3.xml><?xml version="1.0" encoding="utf-8"?>
 <p:sld xmlns:a="http://schemas.openxmlformats.org/drawingml/2006/main" xmlns:r="http://schemas.openxmlformats.org/officeDocument/2006/relationships" xmlns:mc="http://schemas.openxmlformats.org/markup-compatibility/2006" xmlns:mv="urn:schemas-microsoft-com:mac:vml" xmlns:p="http://schemas.openxmlformats.org/presentationml/2006/main" xmlns:c="http://schemas.openxmlformats.org/drawingml/2006/chart" xmlns:dgm="http://schemas.openxmlformats.org/drawingml/2006/diagram" xmlns:o="urn:schemas-microsoft-com:office:office" xmlns:v="urn:schemas-microsoft-com:vml" xmlns:pvml="urn:schemas-microsoft-com:office:powerpoint" xmlns:com="http://schemas.openxmlformats.org/drawingml/2006/compatibility" xmlns:p14="http://schemas.microsoft.com/office/powerpoint/2010/main" xmlns:p15="http://schemas.microsoft.com/office/powerpoint/2012/main" xmlns:ahyp="http://schemas.microsoft.com/office/drawing/2018/hyperlinkcolor">
   <p:cSld>
@@ -16112,6 +16624,174 @@
           </a:ln>
         </p:spPr>
       </p:pic>
+    </p:spTree>
+  </p:cSld>
+  <p:clrMapOvr>
+    <a:masterClrMapping/>
+  </p:clrMapOvr>
+</p:sld>
+</file>
+
+<file path=ppt/slides/slide30.xml><?xml version="1.0" encoding="utf-8"?>
+<p:sld xmlns:a="http://schemas.openxmlformats.org/drawingml/2006/main" xmlns:p="http://schemas.openxmlformats.org/presentationml/2006/main" xmlns:r="http://schemas.openxmlformats.org/officeDocument/2006/relationships">
+  <p:cSld>
+    <p:bg>
+      <p:bgPr>
+        <a:solidFill>
+          <a:srgbClr val="FFFFFF"/>
+        </a:solidFill>
+        <a:effectLst/>
+      </p:bgPr>
+    </p:bg>
+    <p:spTree>
+      <p:nvGrpSpPr>
+        <p:cNvPr id="1" name=""/>
+        <p:cNvGrpSpPr/>
+        <p:nvPr/>
+      </p:nvGrpSpPr>
+      <p:grpSpPr/>
+      <p:pic>
+        <p:nvPicPr>
+          <p:cNvPr id="2" name="Picture 1" descr="fig_library_size_correction.png"/>
+          <p:cNvPicPr>
+            <a:picLocks noChangeAspect="1"/>
+          </p:cNvPicPr>
+          <p:nvPr/>
+        </p:nvPicPr>
+        <p:blipFill>
+          <a:blip r:embed="rId2"/>
+          <a:stretch>
+            <a:fillRect/>
+          </a:stretch>
+        </p:blipFill>
+        <p:spPr>
+          <a:xfrm>
+            <a:off x="914400" y="205740"/>
+            <a:ext cx="10363200" cy="5932170"/>
+          </a:xfrm>
+          <a:prstGeom prst="rect">
+            <a:avLst/>
+          </a:prstGeom>
+        </p:spPr>
+      </p:pic>
+      <p:sp>
+        <p:nvSpPr>
+          <p:cNvPr id="3" name="TextBox 2"/>
+          <p:cNvSpPr txBox="1"/>
+          <p:nvPr/>
+        </p:nvSpPr>
+        <p:spPr>
+          <a:xfrm>
+            <a:off x="609600" y="6206490"/>
+            <a:ext cx="10972800" cy="548640"/>
+          </a:xfrm>
+          <a:prstGeom prst="rect">
+            <a:avLst/>
+          </a:prstGeom>
+          <a:noFill/>
+        </p:spPr>
+        <p:txBody>
+          <a:bodyPr wrap="square">
+            <a:spAutoFit/>
+          </a:bodyPr>
+          <a:lstStyle/>
+          <a:p>
+            <a:pPr algn="ctr"/>
+            <a:r>
+              <a:rPr sz="1300">
+                <a:solidFill>
+                  <a:srgbClr val="444444"/>
+                </a:solidFill>
+              </a:rPr>
+              <a:t>Library-size correction removes depth confound: 98.9% → 33.7% destabilising in neuroblastoma, revealing 66.3% stabilising landscape.</a:t>
+            </a:r>
+          </a:p>
+        </p:txBody>
+      </p:sp>
+    </p:spTree>
+  </p:cSld>
+  <p:clrMapOvr>
+    <a:masterClrMapping/>
+  </p:clrMapOvr>
+</p:sld>
+</file>
+
+<file path=ppt/slides/slide31.xml><?xml version="1.0" encoding="utf-8"?>
+<p:sld xmlns:a="http://schemas.openxmlformats.org/drawingml/2006/main" xmlns:p="http://schemas.openxmlformats.org/presentationml/2006/main" xmlns:r="http://schemas.openxmlformats.org/officeDocument/2006/relationships">
+  <p:cSld>
+    <p:bg>
+      <p:bgPr>
+        <a:solidFill>
+          <a:srgbClr val="FFFFFF"/>
+        </a:solidFill>
+        <a:effectLst/>
+      </p:bgPr>
+    </p:bg>
+    <p:spTree>
+      <p:nvGrpSpPr>
+        <p:cNvPr id="1" name=""/>
+        <p:cNvGrpSpPr/>
+        <p:nvPr/>
+      </p:nvGrpSpPr>
+      <p:grpSpPr/>
+      <p:pic>
+        <p:nvPicPr>
+          <p:cNvPr id="2" name="Picture 1" descr="fig_depmap_essentials.png"/>
+          <p:cNvPicPr>
+            <a:picLocks noChangeAspect="1"/>
+          </p:cNvPicPr>
+          <p:nvPr/>
+        </p:nvPicPr>
+        <p:blipFill>
+          <a:blip r:embed="rId2"/>
+          <a:stretch>
+            <a:fillRect/>
+          </a:stretch>
+        </p:blipFill>
+        <p:spPr>
+          <a:xfrm>
+            <a:off x="914400" y="205740"/>
+            <a:ext cx="10363200" cy="5932170"/>
+          </a:xfrm>
+          <a:prstGeom prst="rect">
+            <a:avLst/>
+          </a:prstGeom>
+        </p:spPr>
+      </p:pic>
+      <p:sp>
+        <p:nvSpPr>
+          <p:cNvPr id="3" name="TextBox 2"/>
+          <p:cNvSpPr txBox="1"/>
+          <p:nvPr/>
+        </p:nvSpPr>
+        <p:spPr>
+          <a:xfrm>
+            <a:off x="609600" y="6206490"/>
+            <a:ext cx="10972800" cy="548640"/>
+          </a:xfrm>
+          <a:prstGeom prst="rect">
+            <a:avLst/>
+          </a:prstGeom>
+          <a:noFill/>
+        </p:spPr>
+        <p:txBody>
+          <a:bodyPr wrap="square">
+            <a:spAutoFit/>
+          </a:bodyPr>
+          <a:lstStyle/>
+          <a:p>
+            <a:pPr algn="ctr"/>
+            <a:r>
+              <a:rPr sz="1300">
+                <a:solidFill>
+                  <a:srgbClr val="444444"/>
+                </a:solidFill>
+              </a:rPr>
+              <a:t>Hub RBPs identified by scPTR are significantly more essential in DepMap CRISPR screens (p=6.4×10⁻⁵).</a:t>
+            </a:r>
+          </a:p>
+        </p:txBody>
+      </p:sp>
     </p:spTree>
   </p:cSld>
   <p:clrMapOvr>

</xml_diff>

<commit_message>
Add discussion summary figure and update slide 23
Two-panel dark figure: left recap (5 key results with stats highlighted),
right future directions (3 numbered items: steady-state relaxation,
eCLIP RBP priors, spatial transcriptomics)
</commit_message>
<xml_diff>
--- a/presentations/scPTR talk.pptx
+++ b/presentations/scPTR talk.pptx
@@ -11102,53 +11102,24 @@
           </a:p>
         </p:txBody>
       </p:sp>
-      <p:sp>
-        <p:nvSpPr>
-          <p:cNvPr id="306" name="FigBg_306"/>
-          <p:cNvSpPr>
-            <a:spLocks noGrp="1"/>
-          </p:cNvSpPr>
-          <p:nvPr/>
-        </p:nvSpPr>
-        <p:spPr>
-          <a:xfrm>
-            <a:off x="365760" y="1442132"/>
-            <a:ext cx="11460480" cy="4110895"/>
-          </a:xfrm>
-          <a:prstGeom prst="roundRect">
-            <a:avLst/>
-          </a:prstGeom>
-          <a:solidFill>
-            <a:srgbClr val="FFFFFF"/>
-          </a:solidFill>
-          <a:ln w="0">
-            <a:noFill/>
-          </a:ln>
-        </p:spPr>
-        <p:txBody>
-          <a:bodyPr/>
-          <a:lstStyle/>
-          <a:p/>
-        </p:txBody>
-      </p:sp>
       <p:pic>
         <p:nvPicPr>
-          <p:cNvPr id="307" name="Picture 306" descr="image.png"/>
+          <p:cNvPr id="306" name="Picture 305" descr="fig_discussion_summary.png"/>
           <p:cNvPicPr>
             <a:picLocks noChangeAspect="1"/>
           </p:cNvPicPr>
           <p:nvPr/>
         </p:nvPicPr>
         <p:blipFill>
-          <a:blip r:embed="rId4"/>
+          <a:blip r:embed="rId5"/>
           <a:stretch>
             <a:fillRect/>
           </a:stretch>
         </p:blipFill>
         <p:spPr>
           <a:xfrm>
-            <a:off x="502920" y="1579292"/>
-            <a:ext cx="11186160" cy="3836575"/>
+            <a:off x="320040" y="861098"/>
+            <a:ext cx="11551920" cy="5135803"/>
           </a:xfrm>
           <a:prstGeom prst="rect">
             <a:avLst/>

</xml_diff>

<commit_message>
Replace slide 16 with expression-vs-gamma recovery figure
New figure shows two panels:
A) Scatter: γ sil vs expression sil for all 19 cell types across
   pancreas and DG. Points in red zone (expr sil < 0) = expression
   completely blind. Epsilon and Pre-endocrine labelled there.
   Most points above y=x diagonal = γ consistently better.
B) Ranked horizontal bar of gap (sil_gamma - sil_expression) for
   all 19 cell types; expr-blind types starred in red.

Directly shows expression clustering does not recover γ-space structure.
</commit_message>
<xml_diff>
--- a/presentations/scPTR talk.pptx
+++ b/presentations/scPTR talk.pptx
@@ -6687,15 +6687,13 @@
       <p:sp>
         <p:nvSpPr>
           <p:cNvPr id="4" name="FigBg_4"/>
-          <p:cNvSpPr>
-            <a:spLocks noGrp="1"/>
-          </p:cNvSpPr>
+          <p:cNvSpPr/>
           <p:nvPr/>
         </p:nvSpPr>
         <p:spPr>
           <a:xfrm>
-            <a:off x="447328" y="914400"/>
-            <a:ext cx="11297344" cy="5166360"/>
+            <a:off x="365760" y="1040214"/>
+            <a:ext cx="11460480" cy="4914732"/>
           </a:xfrm>
           <a:prstGeom prst="roundRect">
             <a:avLst/>
@@ -6715,22 +6713,22 @@
       </p:sp>
       <p:pic>
         <p:nvPicPr>
-          <p:cNvPr id="5" name="Picture 4" descr="image.png"/>
+          <p:cNvPr id="5" name="Picture 4" descr="fig_expression_vs_gamma_recovery.png"/>
           <p:cNvPicPr>
             <a:picLocks noChangeAspect="1"/>
           </p:cNvPicPr>
           <p:nvPr/>
         </p:nvPicPr>
         <p:blipFill>
-          <a:blip r:embed="rId2"/>
+          <a:blip r:embed="rId3"/>
           <a:stretch>
             <a:fillRect/>
           </a:stretch>
         </p:blipFill>
         <p:spPr>
           <a:xfrm>
-            <a:off x="584488" y="1051560"/>
-            <a:ext cx="11023024" cy="4892040"/>
+            <a:off x="502920" y="1177374"/>
+            <a:ext cx="11186160" cy="4640412"/>
           </a:xfrm>
           <a:prstGeom prst="rect">
             <a:avLst/>

</xml_diff>

<commit_message>
Redesign discussion figure: white bg, Times New Roman, simple layout
</commit_message>
<xml_diff>
--- a/presentations/scPTR talk.pptx
+++ b/presentations/scPTR talk.pptx
@@ -11109,15 +11109,15 @@
           <p:nvPr/>
         </p:nvPicPr>
         <p:blipFill>
-          <a:blip r:embed="rId5"/>
+          <a:blip r:embed="rId6"/>
           <a:stretch>
             <a:fillRect/>
           </a:stretch>
         </p:blipFill>
         <p:spPr>
           <a:xfrm>
-            <a:off x="320040" y="861098"/>
-            <a:ext cx="11551920" cy="5135803"/>
+            <a:off x="320040" y="764169"/>
+            <a:ext cx="11551920" cy="5329661"/>
           </a:xfrm>
           <a:prstGeom prst="rect">
             <a:avLst/>

</xml_diff>